<commit_message>
docs: seal-chain decks - artifact retrieval index integrated
Walk deck gains 'Step 0.5 - finding the bytes' (retrieval index entry structure, entry-keyed uniqueness, four resolution outcomes, disposal + sweep discipline); both reference slides cite section 10.85 alongside the existing sections.
</commit_message>
<xml_diff>
--- a/diagrams/compliance/merkle-seal-chain.pptx
+++ b/diagrams/compliance/merkle-seal-chain.pptx
@@ -3397,6 +3397,18 @@
                 <a:latin typeface="Avenir Next"/>
               </a:rPr>
               <a:t>    §10.84 — ordering proofs (a later event binds the hash of an earlier, already-sealed event)</a:t>
+            </a:r>
+          </a:p>
+          <a:p>
+            <a:pPr algn="l"/>
+            <a:r>
+              <a:rPr sz="1500" b="0" i="0">
+                <a:solidFill>
+                  <a:srgbClr val="1B2A41"/>
+                </a:solidFill>
+                <a:latin typeface="Avenir Next"/>
+              </a:rPr>
+              <a:t>    §10.85 — artifact retrieval index: digest→bytes resolution without estate re-hashing</a:t>
             </a:r>
           </a:p>
           <a:p>

</xml_diff>